<commit_message>
feat(examples): AI-glasses launch deck + native-diagram data-font
- examples/ppt169_ai_glasses_launch: a 17-page light keynote product-launch
  deck for a fictional AI smart-glasses product (VEO One), all original content,
  Codex-generated product imagery, a native-diagram capability page; light
  image-as-canvas + flat-vector page system
- retheme examples/ppt169_native_diagram_demo from the generic maturity demo to
  an AI-glasses capability model (02_maturity -> 02_capability)
- native-diagram resolver: add data-font on the placeholder — forces the deck
  typeface onto every spliced run (components keep the source deck's fonts and
  most runs inherit the slide theme, so without it the figure mismatched the
  surrounding text); document it in references/native-diagrams.md

Co-Authored-By: Claude Opus 4.8 <noreply@anthropic.com>
</commit_message>
<xml_diff>
--- a/examples/ppt169_native_diagram_demo/exports/native_diagram_demo.pptx
+++ b/examples/ppt169_native_diagram_demo/exports/native_diagram_demo.pptx
@@ -3106,6 +3106,7 @@
         </p:nvPicPr>
         <p:blipFill>
           <a:blip r:embed="rId2"/>
+          <a:srcRect l="0" t="27" r="0" b="27"/>
           <a:stretch>
             <a:fillRect/>
           </a:stretch>
@@ -3129,14 +3130,14 @@
         <p:spPr>
           <a:xfrm>
             <a:off x="0" y="0"/>
-            <a:ext cx="7239000" cy="6858000"/>
+            <a:ext cx="6858000" cy="6858000"/>
           </a:xfrm>
           <a:prstGeom prst="rect">
             <a:avLst/>
           </a:prstGeom>
           <a:solidFill>
-            <a:srgbClr val="1E3A5F">
-              <a:alpha val="35000"/>
+            <a:srgbClr val="0E1124">
+              <a:alpha val="42000"/>
             </a:srgbClr>
           </a:solidFill>
           <a:ln>
@@ -3153,7 +3154,7 @@
         <p:spPr>
           <a:xfrm>
             <a:off x="796290" y="2529840"/>
-            <a:ext cx="5498592" cy="975360"/>
+            <a:ext cx="3583153" cy="975360"/>
           </a:xfrm>
           <a:prstGeom prst="rect">
             <a:avLst/>
@@ -3179,7 +3180,7 @@
                 <a:ea typeface="Microsoft YaHei"/>
                 <a:cs typeface="Microsoft YaHei"/>
               </a:rPr>
-              <a:t>数字化能力成熟度</a:t>
+              <a:t>AI 智能眼镜</a:t>
             </a:r>
           </a:p>
         </p:txBody>
@@ -3193,7 +3194,7 @@
         <p:spPr>
           <a:xfrm>
             <a:off x="851535" y="3447098"/>
-            <a:ext cx="4470082" cy="396240"/>
+            <a:ext cx="4990148" cy="396240"/>
           </a:xfrm>
           <a:prstGeom prst="rect">
             <a:avLst/>
@@ -3213,13 +3214,13 @@
             <a:r>
               <a:rPr lang="zh-CN" sz="1950" dirty="0">
                 <a:solidFill>
-                  <a:srgbClr val="D4AF37"/>
+                  <a:srgbClr val="18C8D6"/>
                 </a:solidFill>
                 <a:latin typeface="Microsoft YaHei"/>
                 <a:ea typeface="Microsoft YaHei"/>
                 <a:cs typeface="Microsoft YaHei"/>
               </a:rPr>
-              <a:t>从基础数字化到智能化跃迁的三级演进</a:t>
+              <a:t>看见 · 听懂 · 执行 —— 第一视角的智能助手</a:t>
             </a:r>
           </a:p>
         </p:txBody>
@@ -3592,7 +3593,7 @@
         <p:spPr>
           <a:xfrm>
             <a:off x="729615" y="524828"/>
-            <a:ext cx="3278172" cy="518160"/>
+            <a:ext cx="4045818" cy="518160"/>
           </a:xfrm>
           <a:prstGeom prst="rect">
             <a:avLst/>
@@ -3612,13 +3613,13 @@
             <a:r>
               <a:rPr lang="zh-CN" sz="2550" b="1" dirty="0">
                 <a:solidFill>
-                  <a:srgbClr val="1E3A5F"/>
+                  <a:srgbClr val="1B1F3B"/>
                 </a:solidFill>
                 <a:latin typeface="Microsoft YaHei"/>
                 <a:ea typeface="Microsoft YaHei"/>
                 <a:cs typeface="Microsoft YaHei"/>
               </a:rPr>
-              <a:t>能力成熟度三级模型</a:t>
+              <a:t>AI 眼镜能力分层三级模型</a:t>
             </a:r>
           </a:p>
         </p:txBody>
@@ -3638,7 +3639,7 @@
             <a:avLst/>
           </a:prstGeom>
           <a:solidFill>
-            <a:srgbClr val="D4AF37"/>
+            <a:srgbClr val="18C8D6"/>
           </a:solidFill>
           <a:ln>
             <a:noFill/>
@@ -4301,12 +4302,12 @@
             <a:gradFill>
               <a:gsLst>
                 <a:gs pos="0">
-                  <a:srgbClr val="D4AF37">
+                  <a:srgbClr val="1B1F3B">
                     <a:alpha val="53000"/>
                   </a:srgbClr>
                 </a:gs>
                 <a:gs pos="100000">
-                  <a:srgbClr val="D4AF37">
+                  <a:srgbClr val="1B1F3B">
                     <a:alpha val="0"/>
                   </a:srgbClr>
                 </a:gs>
@@ -4319,15 +4320,15 @@
           </p:spPr>
           <p:style>
             <a:lnRef idx="2">
-              <a:srgbClr val="1E3A5F">
+              <a:srgbClr val="18C8D6">
                 <a:shade val="15000"/>
               </a:srgbClr>
             </a:lnRef>
             <a:fillRef idx="1">
-              <a:srgbClr val="1E3A5F"/>
+              <a:srgbClr val="18C8D6"/>
             </a:fillRef>
             <a:effectRef idx="0">
-              <a:srgbClr val="1E3A5F"/>
+              <a:srgbClr val="18C8D6"/>
             </a:effectRef>
             <a:fontRef idx="minor">
               <a:srgbClr val="FFFFFF"/>
@@ -4340,7 +4341,11 @@
             <a:lstStyle/>
             <a:p>
               <a:pPr algn="ctr"/>
-              <a:endParaRPr lang="zh-CN" altLang="en-US"/>
+              <a:endParaRPr lang="zh-CN" altLang="en-US">
+                <a:latin typeface="Microsoft YaHei"/>
+                <a:ea typeface="Microsoft YaHei"/>
+                <a:cs typeface="Microsoft YaHei"/>
+              </a:endParaRPr>
             </a:p>
           </p:txBody>
         </p:sp>
@@ -4367,12 +4372,12 @@
             <a:gradFill>
               <a:gsLst>
                 <a:gs pos="0">
-                  <a:srgbClr val="D4AF37">
+                  <a:srgbClr val="1B1F3B">
                     <a:alpha val="0"/>
                   </a:srgbClr>
                 </a:gs>
                 <a:gs pos="100000">
-                  <a:srgbClr val="D4AF37">
+                  <a:srgbClr val="1B1F3B">
                     <a:alpha val="14000"/>
                   </a:srgbClr>
                 </a:gs>
@@ -4393,15 +4398,15 @@
           </p:spPr>
           <p:style>
             <a:lnRef idx="2">
-              <a:srgbClr val="1E3A5F">
+              <a:srgbClr val="18C8D6">
                 <a:shade val="15000"/>
               </a:srgbClr>
             </a:lnRef>
             <a:fillRef idx="1">
-              <a:srgbClr val="1E3A5F"/>
+              <a:srgbClr val="18C8D6"/>
             </a:fillRef>
             <a:effectRef idx="0">
-              <a:srgbClr val="1E3A5F"/>
+              <a:srgbClr val="18C8D6"/>
             </a:effectRef>
             <a:fontRef idx="minor">
               <a:srgbClr val="FFFFFF"/>
@@ -4412,7 +4417,11 @@
             <a:lstStyle/>
             <a:p>
               <a:pPr algn="ctr"/>
-              <a:endParaRPr lang="zh-CN" altLang="en-US" dirty="0"/>
+              <a:endParaRPr lang="zh-CN" altLang="en-US" dirty="0">
+                <a:latin typeface="Microsoft YaHei"/>
+                <a:ea typeface="Microsoft YaHei"/>
+                <a:cs typeface="Microsoft YaHei"/>
+              </a:endParaRPr>
             </a:p>
           </p:txBody>
         </p:sp>
@@ -4439,12 +4448,12 @@
             <a:gradFill>
               <a:gsLst>
                 <a:gs pos="0">
-                  <a:srgbClr val="1E3A5F">
+                  <a:srgbClr val="18C8D6">
                     <a:alpha val="0"/>
                   </a:srgbClr>
                 </a:gs>
                 <a:gs pos="100000">
-                  <a:srgbClr val="1E3A5F">
+                  <a:srgbClr val="18C8D6">
                     <a:alpha val="11000"/>
                   </a:srgbClr>
                 </a:gs>
@@ -4465,15 +4474,15 @@
           </p:spPr>
           <p:style>
             <a:lnRef idx="2">
-              <a:srgbClr val="1E3A5F">
+              <a:srgbClr val="18C8D6">
                 <a:shade val="15000"/>
               </a:srgbClr>
             </a:lnRef>
             <a:fillRef idx="1">
-              <a:srgbClr val="1E3A5F"/>
+              <a:srgbClr val="18C8D6"/>
             </a:fillRef>
             <a:effectRef idx="0">
-              <a:srgbClr val="1E3A5F"/>
+              <a:srgbClr val="18C8D6"/>
             </a:effectRef>
             <a:fontRef idx="minor">
               <a:srgbClr val="FFFFFF"/>
@@ -4484,7 +4493,11 @@
             <a:lstStyle/>
             <a:p>
               <a:pPr algn="ctr"/>
-              <a:endParaRPr lang="zh-CN" altLang="en-US"/>
+              <a:endParaRPr lang="zh-CN" altLang="en-US">
+                <a:latin typeface="Microsoft YaHei"/>
+                <a:ea typeface="Microsoft YaHei"/>
+                <a:cs typeface="Microsoft YaHei"/>
+              </a:endParaRPr>
             </a:p>
           </p:txBody>
         </p:sp>
@@ -4513,12 +4526,12 @@
               <a:gradFill>
                 <a:gsLst>
                   <a:gs pos="19000">
-                    <a:srgbClr val="1E3A5F">
+                    <a:srgbClr val="18C8D6">
                       <a:alpha val="0"/>
                     </a:srgbClr>
                   </a:gs>
                   <a:gs pos="100000">
-                    <a:srgbClr val="1E3A5F">
+                    <a:srgbClr val="18C8D6">
                       <a:alpha val="50000"/>
                     </a:srgbClr>
                   </a:gs>
@@ -4529,15 +4542,15 @@
           </p:spPr>
           <p:style>
             <a:lnRef idx="2">
-              <a:srgbClr val="1E3A5F">
+              <a:srgbClr val="18C8D6">
                 <a:shade val="15000"/>
               </a:srgbClr>
             </a:lnRef>
             <a:fillRef idx="1">
-              <a:srgbClr val="1E3A5F"/>
+              <a:srgbClr val="18C8D6"/>
             </a:fillRef>
             <a:effectRef idx="0">
-              <a:srgbClr val="1E3A5F"/>
+              <a:srgbClr val="18C8D6"/>
             </a:effectRef>
             <a:fontRef idx="minor">
               <a:srgbClr val="FFFFFF"/>
@@ -4548,7 +4561,11 @@
             <a:lstStyle/>
             <a:p>
               <a:pPr algn="ctr"/>
-              <a:endParaRPr lang="zh-CN" altLang="en-US" sz="2000" dirty="0"/>
+              <a:endParaRPr lang="zh-CN" altLang="en-US" sz="2000" dirty="0">
+                <a:latin typeface="Microsoft YaHei"/>
+                <a:ea typeface="Microsoft YaHei"/>
+                <a:cs typeface="Microsoft YaHei"/>
+              </a:endParaRPr>
             </a:p>
           </p:txBody>
         </p:sp>
@@ -4575,12 +4592,12 @@
             <a:gradFill>
               <a:gsLst>
                 <a:gs pos="0">
-                  <a:srgbClr val="1E3A5F">
+                  <a:srgbClr val="18C8D6">
                     <a:alpha val="0"/>
                   </a:srgbClr>
                 </a:gs>
                 <a:gs pos="100000">
-                  <a:srgbClr val="1E3A5F">
+                  <a:srgbClr val="18C8D6">
                     <a:alpha val="21000"/>
                   </a:srgbClr>
                 </a:gs>
@@ -4601,15 +4618,15 @@
           </p:spPr>
           <p:style>
             <a:lnRef idx="2">
-              <a:srgbClr val="1E3A5F">
+              <a:srgbClr val="18C8D6">
                 <a:shade val="15000"/>
               </a:srgbClr>
             </a:lnRef>
             <a:fillRef idx="1">
-              <a:srgbClr val="1E3A5F"/>
+              <a:srgbClr val="18C8D6"/>
             </a:fillRef>
             <a:effectRef idx="0">
-              <a:srgbClr val="1E3A5F"/>
+              <a:srgbClr val="18C8D6"/>
             </a:effectRef>
             <a:fontRef idx="minor">
               <a:srgbClr val="FFFFFF"/>
@@ -4620,7 +4637,11 @@
             <a:lstStyle/>
             <a:p>
               <a:pPr algn="ctr"/>
-              <a:endParaRPr lang="zh-CN" altLang="en-US" dirty="0"/>
+              <a:endParaRPr lang="zh-CN" altLang="en-US" dirty="0">
+                <a:latin typeface="Microsoft YaHei"/>
+                <a:ea typeface="Microsoft YaHei"/>
+                <a:cs typeface="Microsoft YaHei"/>
+              </a:endParaRPr>
             </a:p>
           </p:txBody>
         </p:sp>
@@ -4649,12 +4670,12 @@
               <a:gradFill>
                 <a:gsLst>
                   <a:gs pos="19000">
-                    <a:srgbClr val="1E3A5F">
+                    <a:srgbClr val="18C8D6">
                       <a:alpha val="0"/>
                     </a:srgbClr>
                   </a:gs>
                   <a:gs pos="100000">
-                    <a:srgbClr val="1E3A5F">
+                    <a:srgbClr val="18C8D6">
                       <a:alpha val="63000"/>
                     </a:srgbClr>
                   </a:gs>
@@ -4665,15 +4686,15 @@
           </p:spPr>
           <p:style>
             <a:lnRef idx="2">
-              <a:srgbClr val="1E3A5F">
+              <a:srgbClr val="18C8D6">
                 <a:shade val="15000"/>
               </a:srgbClr>
             </a:lnRef>
             <a:fillRef idx="1">
-              <a:srgbClr val="1E3A5F"/>
+              <a:srgbClr val="18C8D6"/>
             </a:fillRef>
             <a:effectRef idx="0">
-              <a:srgbClr val="1E3A5F"/>
+              <a:srgbClr val="18C8D6"/>
             </a:effectRef>
             <a:fontRef idx="minor">
               <a:srgbClr val="FFFFFF"/>
@@ -4684,7 +4705,11 @@
             <a:lstStyle/>
             <a:p>
               <a:pPr algn="ctr"/>
-              <a:endParaRPr lang="zh-CN" altLang="en-US" sz="2000"/>
+              <a:endParaRPr lang="zh-CN" altLang="en-US" sz="2000">
+                <a:latin typeface="Microsoft YaHei"/>
+                <a:ea typeface="Microsoft YaHei"/>
+                <a:cs typeface="Microsoft YaHei"/>
+              </a:endParaRPr>
             </a:p>
           </p:txBody>
         </p:sp>
@@ -4713,12 +4738,12 @@
               <a:gradFill>
                 <a:gsLst>
                   <a:gs pos="19000">
-                    <a:srgbClr val="D4AF37">
+                    <a:srgbClr val="1B1F3B">
                       <a:alpha val="0"/>
                     </a:srgbClr>
                   </a:gs>
                   <a:gs pos="100000">
-                    <a:srgbClr val="D4AF37"/>
+                    <a:srgbClr val="1B1F3B"/>
                   </a:gs>
                 </a:gsLst>
                 <a:lin ang="5400000" scaled="1"/>
@@ -4727,15 +4752,15 @@
           </p:spPr>
           <p:style>
             <a:lnRef idx="2">
-              <a:srgbClr val="1E3A5F">
+              <a:srgbClr val="18C8D6">
                 <a:shade val="15000"/>
               </a:srgbClr>
             </a:lnRef>
             <a:fillRef idx="1">
-              <a:srgbClr val="1E3A5F"/>
+              <a:srgbClr val="18C8D6"/>
             </a:fillRef>
             <a:effectRef idx="0">
-              <a:srgbClr val="1E3A5F"/>
+              <a:srgbClr val="18C8D6"/>
             </a:effectRef>
             <a:fontRef idx="minor">
               <a:srgbClr val="FFFFFF"/>
@@ -4746,7 +4771,11 @@
             <a:lstStyle/>
             <a:p>
               <a:pPr algn="ctr"/>
-              <a:endParaRPr lang="zh-CN" altLang="en-US" sz="2000"/>
+              <a:endParaRPr lang="zh-CN" altLang="en-US" sz="2000">
+                <a:latin typeface="Microsoft YaHei"/>
+                <a:ea typeface="Microsoft YaHei"/>
+                <a:cs typeface="Microsoft YaHei"/>
+              </a:endParaRPr>
             </a:p>
           </p:txBody>
         </p:sp>
@@ -4775,21 +4804,21 @@
             </a:solidFill>
             <a:ln w="19050">
               <a:solidFill>
-                <a:srgbClr val="D4AF37"/>
+                <a:srgbClr val="1B1F3B"/>
               </a:solidFill>
             </a:ln>
           </p:spPr>
           <p:style>
             <a:lnRef idx="2">
-              <a:srgbClr val="1E3A5F">
+              <a:srgbClr val="18C8D6">
                 <a:shade val="15000"/>
               </a:srgbClr>
             </a:lnRef>
             <a:fillRef idx="1">
-              <a:srgbClr val="1E3A5F"/>
+              <a:srgbClr val="18C8D6"/>
             </a:fillRef>
             <a:effectRef idx="0">
-              <a:srgbClr val="1E3A5F"/>
+              <a:srgbClr val="18C8D6"/>
             </a:effectRef>
             <a:fontRef idx="minor">
               <a:srgbClr val="FFFFFF"/>
@@ -4800,7 +4829,11 @@
             <a:lstStyle/>
             <a:p>
               <a:pPr algn="ctr"/>
-              <a:endParaRPr lang="zh-CN" altLang="en-US"/>
+              <a:endParaRPr lang="zh-CN" altLang="en-US">
+                <a:latin typeface="Microsoft YaHei"/>
+                <a:ea typeface="Microsoft YaHei"/>
+                <a:cs typeface="Microsoft YaHei"/>
+              </a:endParaRPr>
             </a:p>
           </p:txBody>
         </p:sp>
@@ -4825,7 +4858,7 @@
               <a:avLst/>
             </a:prstGeom>
             <a:solidFill>
-              <a:srgbClr val="D4AF37"/>
+              <a:srgbClr val="1B1F3B"/>
             </a:solidFill>
             <a:ln>
               <a:noFill/>
@@ -4833,15 +4866,15 @@
           </p:spPr>
           <p:style>
             <a:lnRef idx="2">
-              <a:srgbClr val="1E3A5F">
+              <a:srgbClr val="18C8D6">
                 <a:shade val="15000"/>
               </a:srgbClr>
             </a:lnRef>
             <a:fillRef idx="1">
-              <a:srgbClr val="1E3A5F"/>
+              <a:srgbClr val="18C8D6"/>
             </a:fillRef>
             <a:effectRef idx="0">
-              <a:srgbClr val="1E3A5F"/>
+              <a:srgbClr val="18C8D6"/>
             </a:effectRef>
             <a:fontRef idx="minor">
               <a:srgbClr val="FFFFFF"/>
@@ -4852,7 +4885,11 @@
             <a:lstStyle/>
             <a:p>
               <a:pPr algn="ctr"/>
-              <a:endParaRPr lang="zh-CN" altLang="en-US"/>
+              <a:endParaRPr lang="zh-CN" altLang="en-US">
+                <a:latin typeface="Microsoft YaHei"/>
+                <a:ea typeface="Microsoft YaHei"/>
+                <a:cs typeface="Microsoft YaHei"/>
+              </a:endParaRPr>
             </a:p>
           </p:txBody>
         </p:sp>
@@ -4881,21 +4918,21 @@
             </a:solidFill>
             <a:ln w="19050">
               <a:solidFill>
-                <a:srgbClr val="D4AF37"/>
+                <a:srgbClr val="1B1F3B"/>
               </a:solidFill>
             </a:ln>
           </p:spPr>
           <p:style>
             <a:lnRef idx="2">
-              <a:srgbClr val="1E3A5F">
+              <a:srgbClr val="18C8D6">
                 <a:shade val="15000"/>
               </a:srgbClr>
             </a:lnRef>
             <a:fillRef idx="1">
-              <a:srgbClr val="1E3A5F"/>
+              <a:srgbClr val="18C8D6"/>
             </a:fillRef>
             <a:effectRef idx="0">
-              <a:srgbClr val="1E3A5F"/>
+              <a:srgbClr val="18C8D6"/>
             </a:effectRef>
             <a:fontRef idx="minor">
               <a:srgbClr val="FFFFFF"/>
@@ -4906,7 +4943,11 @@
             <a:lstStyle/>
             <a:p>
               <a:pPr algn="ctr"/>
-              <a:endParaRPr lang="zh-CN" altLang="en-US"/>
+              <a:endParaRPr lang="zh-CN" altLang="en-US">
+                <a:latin typeface="Microsoft YaHei"/>
+                <a:ea typeface="Microsoft YaHei"/>
+                <a:cs typeface="Microsoft YaHei"/>
+              </a:endParaRPr>
             </a:p>
           </p:txBody>
         </p:sp>
@@ -4935,21 +4976,21 @@
             </a:solidFill>
             <a:ln w="19050">
               <a:solidFill>
-                <a:srgbClr val="D4AF37"/>
+                <a:srgbClr val="1B1F3B"/>
               </a:solidFill>
             </a:ln>
           </p:spPr>
           <p:style>
             <a:lnRef idx="2">
-              <a:srgbClr val="1E3A5F">
+              <a:srgbClr val="18C8D6">
                 <a:shade val="15000"/>
               </a:srgbClr>
             </a:lnRef>
             <a:fillRef idx="1">
-              <a:srgbClr val="1E3A5F"/>
+              <a:srgbClr val="18C8D6"/>
             </a:fillRef>
             <a:effectRef idx="0">
-              <a:srgbClr val="1E3A5F"/>
+              <a:srgbClr val="18C8D6"/>
             </a:effectRef>
             <a:fontRef idx="minor">
               <a:srgbClr val="FFFFFF"/>
@@ -4960,7 +5001,11 @@
             <a:lstStyle/>
             <a:p>
               <a:pPr algn="ctr"/>
-              <a:endParaRPr lang="zh-CN" altLang="en-US"/>
+              <a:endParaRPr lang="zh-CN" altLang="en-US">
+                <a:latin typeface="Microsoft YaHei"/>
+                <a:ea typeface="Microsoft YaHei"/>
+                <a:cs typeface="Microsoft YaHei"/>
+              </a:endParaRPr>
             </a:p>
           </p:txBody>
         </p:sp>
@@ -4985,7 +5030,7 @@
               <a:avLst/>
             </a:prstGeom>
             <a:solidFill>
-              <a:srgbClr val="D4AF37"/>
+              <a:srgbClr val="1B1F3B"/>
             </a:solidFill>
             <a:ln>
               <a:noFill/>
@@ -4993,15 +5038,15 @@
           </p:spPr>
           <p:style>
             <a:lnRef idx="2">
-              <a:srgbClr val="1E3A5F">
+              <a:srgbClr val="18C8D6">
                 <a:shade val="15000"/>
               </a:srgbClr>
             </a:lnRef>
             <a:fillRef idx="1">
-              <a:srgbClr val="1E3A5F"/>
+              <a:srgbClr val="18C8D6"/>
             </a:fillRef>
             <a:effectRef idx="0">
-              <a:srgbClr val="1E3A5F"/>
+              <a:srgbClr val="18C8D6"/>
             </a:effectRef>
             <a:fontRef idx="minor">
               <a:srgbClr val="FFFFFF"/>
@@ -5012,7 +5057,11 @@
             <a:lstStyle/>
             <a:p>
               <a:pPr algn="ctr"/>
-              <a:endParaRPr lang="zh-CN" altLang="en-US"/>
+              <a:endParaRPr lang="zh-CN" altLang="en-US">
+                <a:latin typeface="Microsoft YaHei"/>
+                <a:ea typeface="Microsoft YaHei"/>
+                <a:cs typeface="Microsoft YaHei"/>
+              </a:endParaRPr>
             </a:p>
           </p:txBody>
         </p:sp>
@@ -5041,21 +5090,21 @@
             </a:solidFill>
             <a:ln w="19050">
               <a:solidFill>
-                <a:srgbClr val="1E3A5F"/>
+                <a:srgbClr val="18C8D6"/>
               </a:solidFill>
             </a:ln>
           </p:spPr>
           <p:style>
             <a:lnRef idx="2">
-              <a:srgbClr val="1E3A5F">
+              <a:srgbClr val="18C8D6">
                 <a:shade val="15000"/>
               </a:srgbClr>
             </a:lnRef>
             <a:fillRef idx="1">
-              <a:srgbClr val="1E3A5F"/>
+              <a:srgbClr val="18C8D6"/>
             </a:fillRef>
             <a:effectRef idx="0">
-              <a:srgbClr val="1E3A5F"/>
+              <a:srgbClr val="18C8D6"/>
             </a:effectRef>
             <a:fontRef idx="minor">
               <a:srgbClr val="FFFFFF"/>
@@ -5066,7 +5115,11 @@
             <a:lstStyle/>
             <a:p>
               <a:pPr algn="ctr"/>
-              <a:endParaRPr lang="zh-CN" altLang="en-US" dirty="0"/>
+              <a:endParaRPr lang="zh-CN" altLang="en-US" dirty="0">
+                <a:latin typeface="Microsoft YaHei"/>
+                <a:ea typeface="Microsoft YaHei"/>
+                <a:cs typeface="Microsoft YaHei"/>
+              </a:endParaRPr>
             </a:p>
           </p:txBody>
         </p:sp>
@@ -5095,21 +5148,21 @@
             </a:solidFill>
             <a:ln w="19050">
               <a:solidFill>
-                <a:srgbClr val="1E3A5F"/>
+                <a:srgbClr val="18C8D6"/>
               </a:solidFill>
             </a:ln>
           </p:spPr>
           <p:style>
             <a:lnRef idx="2">
-              <a:srgbClr val="1E3A5F">
+              <a:srgbClr val="18C8D6">
                 <a:shade val="15000"/>
               </a:srgbClr>
             </a:lnRef>
             <a:fillRef idx="1">
-              <a:srgbClr val="1E3A5F"/>
+              <a:srgbClr val="18C8D6"/>
             </a:fillRef>
             <a:effectRef idx="0">
-              <a:srgbClr val="1E3A5F"/>
+              <a:srgbClr val="18C8D6"/>
             </a:effectRef>
             <a:fontRef idx="minor">
               <a:srgbClr val="FFFFFF"/>
@@ -5120,7 +5173,11 @@
             <a:lstStyle/>
             <a:p>
               <a:pPr algn="ctr"/>
-              <a:endParaRPr lang="zh-CN" altLang="en-US"/>
+              <a:endParaRPr lang="zh-CN" altLang="en-US">
+                <a:latin typeface="Microsoft YaHei"/>
+                <a:ea typeface="Microsoft YaHei"/>
+                <a:cs typeface="Microsoft YaHei"/>
+              </a:endParaRPr>
             </a:p>
           </p:txBody>
         </p:sp>
@@ -5149,21 +5206,21 @@
             </a:solidFill>
             <a:ln w="19050">
               <a:solidFill>
-                <a:srgbClr val="1E3A5F"/>
+                <a:srgbClr val="18C8D6"/>
               </a:solidFill>
             </a:ln>
           </p:spPr>
           <p:style>
             <a:lnRef idx="2">
-              <a:srgbClr val="1E3A5F">
+              <a:srgbClr val="18C8D6">
                 <a:shade val="15000"/>
               </a:srgbClr>
             </a:lnRef>
             <a:fillRef idx="1">
-              <a:srgbClr val="1E3A5F"/>
+              <a:srgbClr val="18C8D6"/>
             </a:fillRef>
             <a:effectRef idx="0">
-              <a:srgbClr val="1E3A5F"/>
+              <a:srgbClr val="18C8D6"/>
             </a:effectRef>
             <a:fontRef idx="minor">
               <a:srgbClr val="FFFFFF"/>
@@ -5174,7 +5231,11 @@
             <a:lstStyle/>
             <a:p>
               <a:pPr algn="ctr"/>
-              <a:endParaRPr lang="zh-CN" altLang="en-US"/>
+              <a:endParaRPr lang="zh-CN" altLang="en-US">
+                <a:latin typeface="Microsoft YaHei"/>
+                <a:ea typeface="Microsoft YaHei"/>
+                <a:cs typeface="Microsoft YaHei"/>
+              </a:endParaRPr>
             </a:p>
           </p:txBody>
         </p:sp>
@@ -5211,27 +5272,30 @@
                   <a:solidFill>
                     <a:srgbClr val="000000"/>
                   </a:solidFill>
-                  <a:latin typeface="微软雅黑" panose="020B0503020204020204" pitchFamily="34" charset="-122"/>
-                  <a:ea typeface="微软雅黑" panose="020B0503020204020204" pitchFamily="34" charset="-122"/>
+                  <a:latin typeface="Microsoft YaHei"/>
+                  <a:ea typeface="Microsoft YaHei"/>
+                  <a:cs typeface="Microsoft YaHei"/>
                 </a:rPr>
-                <a:t>数字化能力</a:t>
+                <a:t>AI 智能眼镜</a:t>
               </a:r>
               <a:r>
                 <a:rPr lang="zh-CN" altLang="en-US" sz="3200" b="1" dirty="0">
                   <a:solidFill>
                     <a:srgbClr val="000000"/>
                   </a:solidFill>
-                  <a:latin typeface="微软雅黑"/>
-                  <a:ea typeface="微软雅黑"/>
+                  <a:latin typeface="Microsoft YaHei"/>
+                  <a:ea typeface="Microsoft YaHei"/>
+                  <a:cs typeface="Microsoft YaHei"/>
                 </a:rPr>
-                <a:t>成熟度模型</a:t>
+                <a:t>能力分层模型</a:t>
               </a:r>
               <a:endParaRPr lang="zh-CN" altLang="en-US" sz="3200" b="1" dirty="0">
                 <a:solidFill>
                   <a:srgbClr val="000000"/>
                 </a:solidFill>
-                <a:latin typeface="微软雅黑" panose="020B0503020204020204" pitchFamily="34" charset="-122"/>
-                <a:ea typeface="微软雅黑" panose="020B0503020204020204" pitchFamily="34" charset="-122"/>
+                <a:latin typeface="Microsoft YaHei"/>
+                <a:ea typeface="Microsoft YaHei"/>
+                <a:cs typeface="Microsoft YaHei"/>
               </a:endParaRPr>
             </a:p>
           </p:txBody>
@@ -5270,13 +5334,19 @@
                   <a:solidFill>
                     <a:srgbClr val="000000"/>
                   </a:solidFill>
+                  <a:latin typeface="Microsoft YaHei"/>
+                  <a:ea typeface="Microsoft YaHei"/>
+                  <a:cs typeface="Microsoft YaHei"/>
                 </a:rPr>
-                <a:t>评估</a:t>
+                <a:t>看见</a:t>
               </a:r>
               <a:endParaRPr lang="en-US" altLang="zh-CN" sz="1200">
                 <a:solidFill>
                   <a:srgbClr val="000000"/>
                 </a:solidFill>
+                <a:latin typeface="Microsoft YaHei"/>
+                <a:ea typeface="Microsoft YaHei"/>
+                <a:cs typeface="Microsoft YaHei"/>
               </a:endParaRPr>
             </a:p>
             <a:p>
@@ -5286,16 +5356,22 @@
                   <a:solidFill>
                     <a:srgbClr val="000000"/>
                   </a:solidFill>
+                  <a:latin typeface="Microsoft YaHei"/>
+                  <a:ea typeface="Microsoft YaHei"/>
+                  <a:cs typeface="Microsoft YaHei"/>
                 </a:rPr>
-                <a:t>规划</a:t>
+                <a:t>听懂</a:t>
               </a:r>
               <a:r>
                 <a:rPr lang="zh-CN" altLang="en-US" sz="1200" dirty="0">
                   <a:solidFill>
                     <a:srgbClr val="000000"/>
                   </a:solidFill>
+                  <a:latin typeface="Microsoft YaHei"/>
+                  <a:ea typeface="Microsoft YaHei"/>
+                  <a:cs typeface="Microsoft YaHei"/>
                 </a:rPr>
-                <a:t>落地</a:t>
+                <a:t>执行</a:t>
               </a:r>
             </a:p>
           </p:txBody>
@@ -5334,8 +5410,11 @@
                   <a:solidFill>
                     <a:srgbClr val="000000"/>
                   </a:solidFill>
+                  <a:latin typeface="Microsoft YaHei"/>
+                  <a:ea typeface="Microsoft YaHei"/>
+                  <a:cs typeface="Microsoft YaHei"/>
                 </a:rPr>
-                <a:t>数据基建</a:t>
+                <a:t>第一视角拍摄</a:t>
               </a:r>
             </a:p>
           </p:txBody>
@@ -5374,8 +5453,11 @@
                   <a:solidFill>
                     <a:srgbClr val="000000"/>
                   </a:solidFill>
+                  <a:latin typeface="Microsoft YaHei"/>
+                  <a:ea typeface="Microsoft YaHei"/>
+                  <a:cs typeface="Microsoft YaHei"/>
                 </a:rPr>
-                <a:t>流程上线</a:t>
+                <a:t>环境识别</a:t>
               </a:r>
             </a:p>
           </p:txBody>
@@ -5414,8 +5496,11 @@
                   <a:solidFill>
                     <a:srgbClr val="000000"/>
                   </a:solidFill>
+                  <a:latin typeface="Microsoft YaHei"/>
+                  <a:ea typeface="Microsoft YaHei"/>
+                  <a:cs typeface="Microsoft YaHei"/>
                 </a:rPr>
-                <a:t>系统打通</a:t>
+                <a:t>语音唤醒</a:t>
               </a:r>
             </a:p>
           </p:txBody>
@@ -5454,8 +5539,11 @@
                   <a:solidFill>
                     <a:srgbClr val="000000"/>
                   </a:solidFill>
+                  <a:latin typeface="Microsoft YaHei"/>
+                  <a:ea typeface="Microsoft YaHei"/>
+                  <a:cs typeface="Microsoft YaHei"/>
                 </a:rPr>
-                <a:t>数据治理</a:t>
+                <a:t>实时翻译</a:t>
               </a:r>
             </a:p>
           </p:txBody>
@@ -5494,8 +5582,11 @@
                   <a:solidFill>
                     <a:srgbClr val="000000"/>
                   </a:solidFill>
+                  <a:latin typeface="Microsoft YaHei"/>
+                  <a:ea typeface="Microsoft YaHei"/>
+                  <a:cs typeface="Microsoft YaHei"/>
                 </a:rPr>
-                <a:t>智能应用</a:t>
+                <a:t>即时导航</a:t>
               </a:r>
             </a:p>
           </p:txBody>
@@ -5525,21 +5616,21 @@
             </a:solidFill>
             <a:ln w="19050">
               <a:solidFill>
-                <a:srgbClr val="1E3A5F"/>
+                <a:srgbClr val="18C8D6"/>
               </a:solidFill>
             </a:ln>
           </p:spPr>
           <p:style>
             <a:lnRef idx="2">
-              <a:srgbClr val="1E3A5F">
+              <a:srgbClr val="18C8D6">
                 <a:shade val="15000"/>
               </a:srgbClr>
             </a:lnRef>
             <a:fillRef idx="1">
-              <a:srgbClr val="1E3A5F"/>
+              <a:srgbClr val="18C8D6"/>
             </a:fillRef>
             <a:effectRef idx="0">
-              <a:srgbClr val="1E3A5F"/>
+              <a:srgbClr val="18C8D6"/>
             </a:effectRef>
             <a:fontRef idx="minor">
               <a:srgbClr val="FFFFFF"/>
@@ -5550,7 +5641,11 @@
             <a:lstStyle/>
             <a:p>
               <a:pPr algn="ctr"/>
-              <a:endParaRPr lang="zh-CN" altLang="en-US" dirty="0"/>
+              <a:endParaRPr lang="zh-CN" altLang="en-US" dirty="0">
+                <a:latin typeface="Microsoft YaHei"/>
+                <a:ea typeface="Microsoft YaHei"/>
+                <a:cs typeface="Microsoft YaHei"/>
+              </a:endParaRPr>
             </a:p>
           </p:txBody>
         </p:sp>
@@ -5579,21 +5674,21 @@
             </a:solidFill>
             <a:ln w="19050">
               <a:solidFill>
-                <a:srgbClr val="1E3A5F"/>
+                <a:srgbClr val="18C8D6"/>
               </a:solidFill>
             </a:ln>
           </p:spPr>
           <p:style>
             <a:lnRef idx="2">
-              <a:srgbClr val="1E3A5F">
+              <a:srgbClr val="18C8D6">
                 <a:shade val="15000"/>
               </a:srgbClr>
             </a:lnRef>
             <a:fillRef idx="1">
-              <a:srgbClr val="1E3A5F"/>
+              <a:srgbClr val="18C8D6"/>
             </a:fillRef>
             <a:effectRef idx="0">
-              <a:srgbClr val="1E3A5F"/>
+              <a:srgbClr val="18C8D6"/>
             </a:effectRef>
             <a:fontRef idx="minor">
               <a:srgbClr val="FFFFFF"/>
@@ -5604,7 +5699,11 @@
             <a:lstStyle/>
             <a:p>
               <a:pPr algn="ctr"/>
-              <a:endParaRPr lang="zh-CN" altLang="en-US"/>
+              <a:endParaRPr lang="zh-CN" altLang="en-US">
+                <a:latin typeface="Microsoft YaHei"/>
+                <a:ea typeface="Microsoft YaHei"/>
+                <a:cs typeface="Microsoft YaHei"/>
+              </a:endParaRPr>
             </a:p>
           </p:txBody>
         </p:sp>
@@ -5633,21 +5732,21 @@
             </a:solidFill>
             <a:ln w="19050">
               <a:solidFill>
-                <a:srgbClr val="1E3A5F"/>
+                <a:srgbClr val="18C8D6"/>
               </a:solidFill>
             </a:ln>
           </p:spPr>
           <p:style>
             <a:lnRef idx="2">
-              <a:srgbClr val="1E3A5F">
+              <a:srgbClr val="18C8D6">
                 <a:shade val="15000"/>
               </a:srgbClr>
             </a:lnRef>
             <a:fillRef idx="1">
-              <a:srgbClr val="1E3A5F"/>
+              <a:srgbClr val="18C8D6"/>
             </a:fillRef>
             <a:effectRef idx="0">
-              <a:srgbClr val="1E3A5F"/>
+              <a:srgbClr val="18C8D6"/>
             </a:effectRef>
             <a:fontRef idx="minor">
               <a:srgbClr val="FFFFFF"/>
@@ -5658,7 +5757,11 @@
             <a:lstStyle/>
             <a:p>
               <a:pPr algn="ctr"/>
-              <a:endParaRPr lang="zh-CN" altLang="en-US"/>
+              <a:endParaRPr lang="zh-CN" altLang="en-US">
+                <a:latin typeface="Microsoft YaHei"/>
+                <a:ea typeface="Microsoft YaHei"/>
+                <a:cs typeface="Microsoft YaHei"/>
+              </a:endParaRPr>
             </a:p>
           </p:txBody>
         </p:sp>
@@ -5696,8 +5799,11 @@
                   <a:solidFill>
                     <a:srgbClr val="000000"/>
                   </a:solidFill>
+                  <a:latin typeface="Microsoft YaHei"/>
+                  <a:ea typeface="Microsoft YaHei"/>
+                  <a:cs typeface="Microsoft YaHei"/>
                 </a:rPr>
-                <a:t>生态协同</a:t>
+                <a:t>信息提醒</a:t>
               </a:r>
             </a:p>
           </p:txBody>
@@ -5736,8 +5842,11 @@
                   <a:solidFill>
                     <a:srgbClr val="000000"/>
                   </a:solidFill>
+                  <a:latin typeface="Microsoft YaHei"/>
+                  <a:ea typeface="Microsoft YaHei"/>
+                  <a:cs typeface="Microsoft YaHei"/>
                 </a:rPr>
-                <a:t>模式创新</a:t>
+                <a:t>多模态助手</a:t>
               </a:r>
             </a:p>
           </p:txBody>
@@ -5776,8 +5885,11 @@
                   <a:solidFill>
                     <a:srgbClr val="000000"/>
                   </a:solidFill>
+                  <a:latin typeface="Microsoft YaHei"/>
+                  <a:ea typeface="Microsoft YaHei"/>
+                  <a:cs typeface="Microsoft YaHei"/>
                 </a:rPr>
-                <a:t>持续进化</a:t>
+                <a:t>应用生态</a:t>
               </a:r>
             </a:p>
           </p:txBody>
@@ -5803,7 +5915,7 @@
               <a:avLst/>
             </a:prstGeom>
             <a:solidFill>
-              <a:srgbClr val="1E3A5F"/>
+              <a:srgbClr val="18C8D6"/>
             </a:solidFill>
             <a:ln>
               <a:noFill/>
@@ -5811,15 +5923,15 @@
           </p:spPr>
           <p:style>
             <a:lnRef idx="2">
-              <a:srgbClr val="1E3A5F">
+              <a:srgbClr val="18C8D6">
                 <a:shade val="15000"/>
               </a:srgbClr>
             </a:lnRef>
             <a:fillRef idx="1">
-              <a:srgbClr val="1E3A5F"/>
+              <a:srgbClr val="18C8D6"/>
             </a:fillRef>
             <a:effectRef idx="0">
-              <a:srgbClr val="1E3A5F"/>
+              <a:srgbClr val="18C8D6"/>
             </a:effectRef>
             <a:fontRef idx="minor">
               <a:srgbClr val="FFFFFF"/>
@@ -5830,7 +5942,11 @@
             <a:lstStyle/>
             <a:p>
               <a:pPr algn="ctr"/>
-              <a:endParaRPr lang="zh-CN" altLang="en-US"/>
+              <a:endParaRPr lang="zh-CN" altLang="en-US">
+                <a:latin typeface="Microsoft YaHei"/>
+                <a:ea typeface="Microsoft YaHei"/>
+                <a:cs typeface="Microsoft YaHei"/>
+              </a:endParaRPr>
             </a:p>
           </p:txBody>
         </p:sp>
@@ -5855,7 +5971,7 @@
               <a:avLst/>
             </a:prstGeom>
             <a:solidFill>
-              <a:srgbClr val="1E3A5F"/>
+              <a:srgbClr val="18C8D6"/>
             </a:solidFill>
             <a:ln>
               <a:noFill/>
@@ -5863,15 +5979,15 @@
           </p:spPr>
           <p:style>
             <a:lnRef idx="2">
-              <a:srgbClr val="1E3A5F">
+              <a:srgbClr val="18C8D6">
                 <a:shade val="15000"/>
               </a:srgbClr>
             </a:lnRef>
             <a:fillRef idx="1">
-              <a:srgbClr val="1E3A5F"/>
+              <a:srgbClr val="18C8D6"/>
             </a:fillRef>
             <a:effectRef idx="0">
-              <a:srgbClr val="1E3A5F"/>
+              <a:srgbClr val="18C8D6"/>
             </a:effectRef>
             <a:fontRef idx="minor">
               <a:srgbClr val="FFFFFF"/>
@@ -5882,7 +5998,11 @@
             <a:lstStyle/>
             <a:p>
               <a:pPr algn="ctr"/>
-              <a:endParaRPr lang="zh-CN" altLang="en-US"/>
+              <a:endParaRPr lang="zh-CN" altLang="en-US">
+                <a:latin typeface="Microsoft YaHei"/>
+                <a:ea typeface="Microsoft YaHei"/>
+                <a:cs typeface="Microsoft YaHei"/>
+              </a:endParaRPr>
             </a:p>
           </p:txBody>
         </p:sp>
@@ -5907,7 +6027,7 @@
               <a:avLst/>
             </a:prstGeom>
             <a:solidFill>
-              <a:srgbClr val="1E3A5F"/>
+              <a:srgbClr val="18C8D6"/>
             </a:solidFill>
             <a:ln>
               <a:noFill/>
@@ -5915,15 +6035,15 @@
           </p:spPr>
           <p:style>
             <a:lnRef idx="2">
-              <a:srgbClr val="1E3A5F">
+              <a:srgbClr val="18C8D6">
                 <a:shade val="15000"/>
               </a:srgbClr>
             </a:lnRef>
             <a:fillRef idx="1">
-              <a:srgbClr val="1E3A5F"/>
+              <a:srgbClr val="18C8D6"/>
             </a:fillRef>
             <a:effectRef idx="0">
-              <a:srgbClr val="1E3A5F"/>
+              <a:srgbClr val="18C8D6"/>
             </a:effectRef>
             <a:fontRef idx="minor">
               <a:srgbClr val="FFFFFF"/>
@@ -5934,7 +6054,11 @@
             <a:lstStyle/>
             <a:p>
               <a:pPr algn="ctr"/>
-              <a:endParaRPr lang="zh-CN" altLang="en-US"/>
+              <a:endParaRPr lang="zh-CN" altLang="en-US">
+                <a:latin typeface="Microsoft YaHei"/>
+                <a:ea typeface="Microsoft YaHei"/>
+                <a:cs typeface="Microsoft YaHei"/>
+              </a:endParaRPr>
             </a:p>
           </p:txBody>
         </p:sp>
@@ -5959,7 +6083,7 @@
               <a:avLst/>
             </a:prstGeom>
             <a:solidFill>
-              <a:srgbClr val="1E3A5F"/>
+              <a:srgbClr val="18C8D6"/>
             </a:solidFill>
             <a:ln>
               <a:noFill/>
@@ -5967,15 +6091,15 @@
           </p:spPr>
           <p:style>
             <a:lnRef idx="2">
-              <a:srgbClr val="1E3A5F">
+              <a:srgbClr val="18C8D6">
                 <a:shade val="15000"/>
               </a:srgbClr>
             </a:lnRef>
             <a:fillRef idx="1">
-              <a:srgbClr val="1E3A5F"/>
+              <a:srgbClr val="18C8D6"/>
             </a:fillRef>
             <a:effectRef idx="0">
-              <a:srgbClr val="1E3A5F"/>
+              <a:srgbClr val="18C8D6"/>
             </a:effectRef>
             <a:fontRef idx="minor">
               <a:srgbClr val="FFFFFF"/>
@@ -5986,7 +6110,11 @@
             <a:lstStyle/>
             <a:p>
               <a:pPr algn="ctr"/>
-              <a:endParaRPr lang="zh-CN" altLang="en-US"/>
+              <a:endParaRPr lang="zh-CN" altLang="en-US">
+                <a:latin typeface="Microsoft YaHei"/>
+                <a:ea typeface="Microsoft YaHei"/>
+                <a:cs typeface="Microsoft YaHei"/>
+              </a:endParaRPr>
             </a:p>
           </p:txBody>
         </p:sp>
@@ -6022,10 +6150,13 @@
               <a:r>
                 <a:rPr lang="zh-CN" altLang="en-US" b="1" dirty="0">
                   <a:solidFill>
-                    <a:srgbClr val="D4AF37"/>
+                    <a:srgbClr val="1B1F3B"/>
                   </a:solidFill>
+                  <a:latin typeface="Microsoft YaHei"/>
+                  <a:ea typeface="Microsoft YaHei"/>
+                  <a:cs typeface="Microsoft YaHei"/>
                 </a:rPr>
-                <a:t>L1 基础数字化</a:t>
+                <a:t>L1 感知硬件</a:t>
               </a:r>
             </a:p>
           </p:txBody>
@@ -6062,10 +6193,13 @@
               <a:r>
                 <a:rPr lang="zh-CN" altLang="en-US" b="1" dirty="0">
                   <a:solidFill>
-                    <a:srgbClr val="1E3A5F"/>
+                    <a:srgbClr val="18C8D6"/>
                   </a:solidFill>
+                  <a:latin typeface="Microsoft YaHei"/>
+                  <a:ea typeface="Microsoft YaHei"/>
+                  <a:cs typeface="Microsoft YaHei"/>
                 </a:rPr>
-                <a:t>L3 智能化跃迁</a:t>
+                <a:t>L3 智能生态</a:t>
               </a:r>
             </a:p>
           </p:txBody>
@@ -6102,10 +6236,13 @@
               <a:r>
                 <a:rPr lang="zh-CN" altLang="en-US" b="1" dirty="0">
                   <a:solidFill>
-                    <a:srgbClr val="1E3A5F"/>
+                    <a:srgbClr val="18C8D6"/>
                   </a:solidFill>
+                  <a:latin typeface="Microsoft YaHei"/>
+                  <a:ea typeface="Microsoft YaHei"/>
+                  <a:cs typeface="Microsoft YaHei"/>
                 </a:rPr>
-                <a:t>L2 平台化整合</a:t>
+                <a:t>L2 实时交互</a:t>
               </a:r>
             </a:p>
           </p:txBody>

</xml_diff>